<commit_message>
Weekly deck v2: E3 results, smaller artifacts, Google Slides instructions
- Slide 8 rebuilt now that the classical matrix is complete: E3 scaling
  figure (per-seed points + median lines, n in {3,4,6,8}), status strip
  '460/460 classical cells complete, 0 failures', and a scaling finding
  that is explicitly labelled descriptive - the n=8 search-vs-reference
  gap is large (T2 median RMSE 0.295 vs 0.050, 5/5 paired replicates)
  but with 5 replicates the smallest attainable paired p is 0.0625, so
  no Holm-corrected significance is claimed.
- Slide 10 next-steps updated (classical matrix done).
- build_deck_figures.py: palette-quantize PNGs; recompress_pptx.py
  deflates the pptxgenjs zip (949 KB -> 277 KB total for the deck).
- README documents the Google Slides publishing steps and why the
  upload could not be automated from this session.

Co-Authored-By: Claude Fable 5 <noreply@anthropic.com>
</commit_message>
<xml_diff>
--- a/docs/presentation/bench_v2_weekly/LLM_VQC_weekly_benchmark_v2.pptx
+++ b/docs/presentation/bench_v2_weekly/LLM_VQC_weekly_benchmark_v2.pptx
@@ -2035,7 +2035,7 @@
                 <a:ea typeface="Calibri" pitchFamily="34" charset="-122"/>
                 <a:cs typeface="Calibri" pitchFamily="34" charset="-120"/>
               </a:rPr>
-              <a:t>Finish + verify E3 scaling (n ∈ {3,4,6,8}; running, resumable, ~120 classical cells)</a:t>
+              <a:t>Classical matrix is done: 460 / 460 cells, 0 failures, n=8 actually simulated</a:t>
             </a:r>
             <a:endParaRPr lang="en-US" sz="1500" dirty="0"/>
           </a:p>
@@ -6938,7 +6938,7 @@
                 <a:ea typeface="Calibri" pitchFamily="34" charset="-122"/>
                 <a:cs typeface="Calibri" pitchFamily="34" charset="-120"/>
               </a:rPr>
-              <a:t>RESULTS — MAIN MATRIX</a:t>
+              <a:t>RESULTS — MAIN MATRIX (COMPLETE)</a:t>
             </a:r>
             <a:endParaRPr lang="en-US" sz="1100" dirty="0"/>
           </a:p>
@@ -6977,7 +6977,7 @@
                 <a:ea typeface="Cambria" pitchFamily="34" charset="-122"/>
                 <a:cs typeface="Cambria" pitchFamily="34" charset="-120"/>
               </a:rPr>
-              <a:t>E2 classical matrix complete; E3 scaling is running now</a:t>
+              <a:t>Classical matrix complete: E2 at n=5, E3 scaling to 8 qubits</a:t>
             </a:r>
             <a:endParaRPr lang="en-US" sz="3000" dirty="0"/>
           </a:p>
@@ -6999,8 +6999,8 @@
         </p:blipFill>
         <p:spPr>
           <a:xfrm>
-            <a:off x="457200" y="1417320"/>
-            <a:ext cx="8503920" cy="2240280"/>
+            <a:off x="457200" y="1325880"/>
+            <a:ext cx="7178040" cy="1792224"/>
           </a:xfrm>
           <a:prstGeom prst="rect">
             <a:avLst/>
@@ -7023,1246 +7023,77 @@
         </p:blipFill>
         <p:spPr>
           <a:xfrm>
-            <a:off x="457200" y="3794760"/>
-            <a:ext cx="8503920" cy="1920240"/>
+            <a:off x="457200" y="3246120"/>
+            <a:ext cx="7178040" cy="1563624"/>
           </a:xfrm>
           <a:prstGeom prst="rect">
             <a:avLst/>
           </a:prstGeom>
         </p:spPr>
       </p:pic>
-      <p:graphicFrame>
-        <p:nvGraphicFramePr>
-          <p:cNvPr id="9" name="Table 0"/>
-          <p:cNvGraphicFramePr>
-            <a:graphicFrameLocks noGrp="1"/>
-          </p:cNvGraphicFramePr>
-          <p:nvPr>
-            <p:extLst>
-              <p:ext uri="{D42A27DB-BD31-4B8C-83A1-F6EECF244321}">
-                <p14:modId xmlns:p14="http://schemas.microsoft.com/office/powerpoint/2010/main" val="1579011935"/>
-              </p:ext>
-            </p:extLst>
-          </p:nvPr>
-        </p:nvGraphicFramePr>
-        <p:xfrm>
-          <a:off x="9144000" y="1463040"/>
-          <a:ext cx="2606040" cy="914400"/>
-        </p:xfrm>
-        <a:graphic>
-          <a:graphicData uri="http://schemas.openxmlformats.org/drawingml/2006/table">
-            <a:tbl>
-              <a:tblPr/>
-              <a:tblGrid>
-                <a:gridCol w="1325880"/>
-                <a:gridCol w="548640"/>
-                <a:gridCol w="731520"/>
-              </a:tblGrid>
-              <a:tr h="310896">
-                <a:tc>
-                  <a:txBody>
-                    <a:bodyPr/>
-                    <a:lstStyle/>
-                    <a:p>
-                      <a:pPr indent="0" marL="0">
-                        <a:buNone/>
-                      </a:pPr>
-                      <a:r>
-                        <a:rPr lang="en-US" sz="950" b="1" dirty="0">
-                          <a:solidFill>
-                            <a:srgbClr val="FFFFFF"/>
-                          </a:solidFill>
-                          <a:latin typeface="Calibri" pitchFamily="34" charset="0"/>
-                          <a:ea typeface="Calibri" pitchFamily="34" charset="-122"/>
-                          <a:cs typeface="Calibri" pitchFamily="34" charset="-120"/>
-                        </a:rPr>
-                        <a:t>cells</a:t>
-                      </a:r>
-                      <a:endParaRPr lang="en-US" sz="950" dirty="0">
-                        <a:latin typeface="Calibri" charset="0"/>
-                        <a:ea typeface="Calibri" charset="0"/>
-                        <a:cs typeface="Calibri" charset="0"/>
-                      </a:endParaRPr>
-                    </a:p>
-                  </a:txBody>
-                  <a:tcPr marL="36576" marR="36576" marT="36576" marB="36576" anchor="ctr">
-                    <a:lnL w="6350" cap="flat" cmpd="sng" algn="ctr">
-                      <a:solidFill>
-                        <a:srgbClr val="D8DDE8"/>
-                      </a:solidFill>
-                      <a:prstDash val="solid"/>
-                      <a:round/>
-                      <a:headEnd type="none" w="med" len="med"/>
-                      <a:tailEnd type="none" w="med" len="med"/>
-                    </a:lnL>
-                    <a:lnR w="6350" cap="flat" cmpd="sng" algn="ctr">
-                      <a:solidFill>
-                        <a:srgbClr val="D8DDE8"/>
-                      </a:solidFill>
-                      <a:prstDash val="solid"/>
-                      <a:round/>
-                      <a:headEnd type="none" w="med" len="med"/>
-                      <a:tailEnd type="none" w="med" len="med"/>
-                    </a:lnR>
-                    <a:lnT w="6350" cap="flat" cmpd="sng" algn="ctr">
-                      <a:solidFill>
-                        <a:srgbClr val="D8DDE8"/>
-                      </a:solidFill>
-                      <a:prstDash val="solid"/>
-                      <a:round/>
-                      <a:headEnd type="none" w="med" len="med"/>
-                      <a:tailEnd type="none" w="med" len="med"/>
-                    </a:lnT>
-                    <a:lnB w="6350" cap="flat" cmpd="sng" algn="ctr">
-                      <a:solidFill>
-                        <a:srgbClr val="D8DDE8"/>
-                      </a:solidFill>
-                      <a:prstDash val="solid"/>
-                      <a:round/>
-                      <a:headEnd type="none" w="med" len="med"/>
-                      <a:tailEnd type="none" w="med" len="med"/>
-                    </a:lnB>
-                    <a:solidFill>
-                      <a:srgbClr val="1E2761"/>
-                    </a:solidFill>
-                  </a:tcPr>
-                </a:tc>
-                <a:tc>
-                  <a:txBody>
-                    <a:bodyPr/>
-                    <a:lstStyle/>
-                    <a:p>
-                      <a:pPr indent="0" marL="0">
-                        <a:buNone/>
-                      </a:pPr>
-                      <a:r>
-                        <a:rPr lang="en-US" sz="950" b="1" dirty="0">
-                          <a:solidFill>
-                            <a:srgbClr val="FFFFFF"/>
-                          </a:solidFill>
-                          <a:latin typeface="Calibri" pitchFamily="34" charset="0"/>
-                          <a:ea typeface="Calibri" pitchFamily="34" charset="-122"/>
-                          <a:cs typeface="Calibri" pitchFamily="34" charset="-120"/>
-                        </a:rPr>
-                        <a:t>done</a:t>
-                      </a:r>
-                      <a:endParaRPr lang="en-US" sz="950" dirty="0">
-                        <a:latin typeface="Calibri" charset="0"/>
-                        <a:ea typeface="Calibri" charset="0"/>
-                        <a:cs typeface="Calibri" charset="0"/>
-                      </a:endParaRPr>
-                    </a:p>
-                  </a:txBody>
-                  <a:tcPr marL="36576" marR="36576" marT="36576" marB="36576" anchor="ctr">
-                    <a:lnL w="6350" cap="flat" cmpd="sng" algn="ctr">
-                      <a:solidFill>
-                        <a:srgbClr val="D8DDE8"/>
-                      </a:solidFill>
-                      <a:prstDash val="solid"/>
-                      <a:round/>
-                      <a:headEnd type="none" w="med" len="med"/>
-                      <a:tailEnd type="none" w="med" len="med"/>
-                    </a:lnL>
-                    <a:lnR w="6350" cap="flat" cmpd="sng" algn="ctr">
-                      <a:solidFill>
-                        <a:srgbClr val="D8DDE8"/>
-                      </a:solidFill>
-                      <a:prstDash val="solid"/>
-                      <a:round/>
-                      <a:headEnd type="none" w="med" len="med"/>
-                      <a:tailEnd type="none" w="med" len="med"/>
-                    </a:lnR>
-                    <a:lnT w="6350" cap="flat" cmpd="sng" algn="ctr">
-                      <a:solidFill>
-                        <a:srgbClr val="D8DDE8"/>
-                      </a:solidFill>
-                      <a:prstDash val="solid"/>
-                      <a:round/>
-                      <a:headEnd type="none" w="med" len="med"/>
-                      <a:tailEnd type="none" w="med" len="med"/>
-                    </a:lnT>
-                    <a:lnB w="6350" cap="flat" cmpd="sng" algn="ctr">
-                      <a:solidFill>
-                        <a:srgbClr val="D8DDE8"/>
-                      </a:solidFill>
-                      <a:prstDash val="solid"/>
-                      <a:round/>
-                      <a:headEnd type="none" w="med" len="med"/>
-                      <a:tailEnd type="none" w="med" len="med"/>
-                    </a:lnB>
-                    <a:solidFill>
-                      <a:srgbClr val="1E2761"/>
-                    </a:solidFill>
-                  </a:tcPr>
-                </a:tc>
-                <a:tc>
-                  <a:txBody>
-                    <a:bodyPr/>
-                    <a:lstStyle/>
-                    <a:p>
-                      <a:pPr indent="0" marL="0">
-                        <a:buNone/>
-                      </a:pPr>
-                      <a:r>
-                        <a:rPr lang="en-US" sz="950" b="1" dirty="0">
-                          <a:solidFill>
-                            <a:srgbClr val="FFFFFF"/>
-                          </a:solidFill>
-                          <a:latin typeface="Calibri" pitchFamily="34" charset="0"/>
-                          <a:ea typeface="Calibri" pitchFamily="34" charset="-122"/>
-                          <a:cs typeface="Calibri" pitchFamily="34" charset="-120"/>
-                        </a:rPr>
-                        <a:t>state</a:t>
-                      </a:r>
-                      <a:endParaRPr lang="en-US" sz="950" dirty="0">
-                        <a:latin typeface="Calibri" charset="0"/>
-                        <a:ea typeface="Calibri" charset="0"/>
-                        <a:cs typeface="Calibri" charset="0"/>
-                      </a:endParaRPr>
-                    </a:p>
-                  </a:txBody>
-                  <a:tcPr marL="36576" marR="36576" marT="36576" marB="36576" anchor="ctr">
-                    <a:lnL w="6350" cap="flat" cmpd="sng" algn="ctr">
-                      <a:solidFill>
-                        <a:srgbClr val="D8DDE8"/>
-                      </a:solidFill>
-                      <a:prstDash val="solid"/>
-                      <a:round/>
-                      <a:headEnd type="none" w="med" len="med"/>
-                      <a:tailEnd type="none" w="med" len="med"/>
-                    </a:lnL>
-                    <a:lnR w="6350" cap="flat" cmpd="sng" algn="ctr">
-                      <a:solidFill>
-                        <a:srgbClr val="D8DDE8"/>
-                      </a:solidFill>
-                      <a:prstDash val="solid"/>
-                      <a:round/>
-                      <a:headEnd type="none" w="med" len="med"/>
-                      <a:tailEnd type="none" w="med" len="med"/>
-                    </a:lnR>
-                    <a:lnT w="6350" cap="flat" cmpd="sng" algn="ctr">
-                      <a:solidFill>
-                        <a:srgbClr val="D8DDE8"/>
-                      </a:solidFill>
-                      <a:prstDash val="solid"/>
-                      <a:round/>
-                      <a:headEnd type="none" w="med" len="med"/>
-                      <a:tailEnd type="none" w="med" len="med"/>
-                    </a:lnT>
-                    <a:lnB w="6350" cap="flat" cmpd="sng" algn="ctr">
-                      <a:solidFill>
-                        <a:srgbClr val="D8DDE8"/>
-                      </a:solidFill>
-                      <a:prstDash val="solid"/>
-                      <a:round/>
-                      <a:headEnd type="none" w="med" len="med"/>
-                      <a:tailEnd type="none" w="med" len="med"/>
-                    </a:lnB>
-                    <a:solidFill>
-                      <a:srgbClr val="1E2761"/>
-                    </a:solidFill>
-                  </a:tcPr>
-                </a:tc>
-              </a:tr>
-              <a:tr h="310896">
-                <a:tc>
-                  <a:txBody>
-                    <a:bodyPr/>
-                    <a:lstStyle/>
-                    <a:p>
-                      <a:pPr indent="0" marL="0">
-                        <a:buNone/>
-                      </a:pPr>
-                      <a:r>
-                        <a:rPr lang="en-US" sz="950" dirty="0">
-                          <a:solidFill>
-                            <a:srgbClr val="000000"/>
-                          </a:solidFill>
-                          <a:latin typeface="Calibri" pitchFamily="34" charset="0"/>
-                          <a:ea typeface="Calibri" pitchFamily="34" charset="-122"/>
-                          <a:cs typeface="Calibri" pitchFamily="34" charset="-120"/>
-                        </a:rPr>
-                        <a:t>E1 classical (60)</a:t>
-                      </a:r>
-                      <a:endParaRPr lang="en-US" sz="950" dirty="0">
-                        <a:latin typeface="Calibri" charset="0"/>
-                        <a:ea typeface="Calibri" charset="0"/>
-                        <a:cs typeface="Calibri" charset="0"/>
-                      </a:endParaRPr>
-                    </a:p>
-                  </a:txBody>
-                  <a:tcPr marL="36576" marR="36576" marT="36576" marB="36576" anchor="ctr">
-                    <a:lnL w="6350" cap="flat" cmpd="sng" algn="ctr">
-                      <a:solidFill>
-                        <a:srgbClr val="D8DDE8"/>
-                      </a:solidFill>
-                      <a:prstDash val="solid"/>
-                      <a:round/>
-                      <a:headEnd type="none" w="med" len="med"/>
-                      <a:tailEnd type="none" w="med" len="med"/>
-                    </a:lnL>
-                    <a:lnR w="6350" cap="flat" cmpd="sng" algn="ctr">
-                      <a:solidFill>
-                        <a:srgbClr val="D8DDE8"/>
-                      </a:solidFill>
-                      <a:prstDash val="solid"/>
-                      <a:round/>
-                      <a:headEnd type="none" w="med" len="med"/>
-                      <a:tailEnd type="none" w="med" len="med"/>
-                    </a:lnR>
-                    <a:lnT w="6350" cap="flat" cmpd="sng" algn="ctr">
-                      <a:solidFill>
-                        <a:srgbClr val="D8DDE8"/>
-                      </a:solidFill>
-                      <a:prstDash val="solid"/>
-                      <a:round/>
-                      <a:headEnd type="none" w="med" len="med"/>
-                      <a:tailEnd type="none" w="med" len="med"/>
-                    </a:lnT>
-                    <a:lnB w="6350" cap="flat" cmpd="sng" algn="ctr">
-                      <a:solidFill>
-                        <a:srgbClr val="D8DDE8"/>
-                      </a:solidFill>
-                      <a:prstDash val="solid"/>
-                      <a:round/>
-                      <a:headEnd type="none" w="med" len="med"/>
-                      <a:tailEnd type="none" w="med" len="med"/>
-                    </a:lnB>
-                  </a:tcPr>
-                </a:tc>
-                <a:tc>
-                  <a:txBody>
-                    <a:bodyPr/>
-                    <a:lstStyle/>
-                    <a:p>
-                      <a:pPr indent="0" marL="0">
-                        <a:buNone/>
-                      </a:pPr>
-                      <a:r>
-                        <a:rPr lang="en-US" sz="950" dirty="0">
-                          <a:solidFill>
-                            <a:srgbClr val="000000"/>
-                          </a:solidFill>
-                          <a:latin typeface="Calibri" pitchFamily="34" charset="0"/>
-                          <a:ea typeface="Calibri" pitchFamily="34" charset="-122"/>
-                          <a:cs typeface="Calibri" pitchFamily="34" charset="-120"/>
-                        </a:rPr>
-                        <a:t>60</a:t>
-                      </a:r>
-                      <a:endParaRPr lang="en-US" sz="950" dirty="0">
-                        <a:latin typeface="Calibri" charset="0"/>
-                        <a:ea typeface="Calibri" charset="0"/>
-                        <a:cs typeface="Calibri" charset="0"/>
-                      </a:endParaRPr>
-                    </a:p>
-                  </a:txBody>
-                  <a:tcPr marL="36576" marR="36576" marT="36576" marB="36576" anchor="ctr">
-                    <a:lnL w="6350" cap="flat" cmpd="sng" algn="ctr">
-                      <a:solidFill>
-                        <a:srgbClr val="D8DDE8"/>
-                      </a:solidFill>
-                      <a:prstDash val="solid"/>
-                      <a:round/>
-                      <a:headEnd type="none" w="med" len="med"/>
-                      <a:tailEnd type="none" w="med" len="med"/>
-                    </a:lnL>
-                    <a:lnR w="6350" cap="flat" cmpd="sng" algn="ctr">
-                      <a:solidFill>
-                        <a:srgbClr val="D8DDE8"/>
-                      </a:solidFill>
-                      <a:prstDash val="solid"/>
-                      <a:round/>
-                      <a:headEnd type="none" w="med" len="med"/>
-                      <a:tailEnd type="none" w="med" len="med"/>
-                    </a:lnR>
-                    <a:lnT w="6350" cap="flat" cmpd="sng" algn="ctr">
-                      <a:solidFill>
-                        <a:srgbClr val="D8DDE8"/>
-                      </a:solidFill>
-                      <a:prstDash val="solid"/>
-                      <a:round/>
-                      <a:headEnd type="none" w="med" len="med"/>
-                      <a:tailEnd type="none" w="med" len="med"/>
-                    </a:lnT>
-                    <a:lnB w="6350" cap="flat" cmpd="sng" algn="ctr">
-                      <a:solidFill>
-                        <a:srgbClr val="D8DDE8"/>
-                      </a:solidFill>
-                      <a:prstDash val="solid"/>
-                      <a:round/>
-                      <a:headEnd type="none" w="med" len="med"/>
-                      <a:tailEnd type="none" w="med" len="med"/>
-                    </a:lnB>
-                  </a:tcPr>
-                </a:tc>
-                <a:tc>
-                  <a:txBody>
-                    <a:bodyPr/>
-                    <a:lstStyle/>
-                    <a:p>
-                      <a:pPr indent="0" marL="0">
-                        <a:buNone/>
-                      </a:pPr>
-                      <a:r>
-                        <a:rPr lang="en-US" sz="950" b="1" dirty="0">
-                          <a:solidFill>
-                            <a:srgbClr val="2C5F2D"/>
-                          </a:solidFill>
-                          <a:latin typeface="Calibri" pitchFamily="34" charset="0"/>
-                          <a:ea typeface="Calibri" pitchFamily="34" charset="-122"/>
-                          <a:cs typeface="Calibri" pitchFamily="34" charset="-120"/>
-                        </a:rPr>
-                        <a:t>complete</a:t>
-                      </a:r>
-                      <a:endParaRPr lang="en-US" sz="950" dirty="0">
-                        <a:latin typeface="Calibri" charset="0"/>
-                        <a:ea typeface="Calibri" charset="0"/>
-                        <a:cs typeface="Calibri" charset="0"/>
-                      </a:endParaRPr>
-                    </a:p>
-                  </a:txBody>
-                  <a:tcPr marL="36576" marR="36576" marT="36576" marB="36576" anchor="ctr">
-                    <a:lnL w="6350" cap="flat" cmpd="sng" algn="ctr">
-                      <a:solidFill>
-                        <a:srgbClr val="D8DDE8"/>
-                      </a:solidFill>
-                      <a:prstDash val="solid"/>
-                      <a:round/>
-                      <a:headEnd type="none" w="med" len="med"/>
-                      <a:tailEnd type="none" w="med" len="med"/>
-                    </a:lnL>
-                    <a:lnR w="6350" cap="flat" cmpd="sng" algn="ctr">
-                      <a:solidFill>
-                        <a:srgbClr val="D8DDE8"/>
-                      </a:solidFill>
-                      <a:prstDash val="solid"/>
-                      <a:round/>
-                      <a:headEnd type="none" w="med" len="med"/>
-                      <a:tailEnd type="none" w="med" len="med"/>
-                    </a:lnR>
-                    <a:lnT w="6350" cap="flat" cmpd="sng" algn="ctr">
-                      <a:solidFill>
-                        <a:srgbClr val="D8DDE8"/>
-                      </a:solidFill>
-                      <a:prstDash val="solid"/>
-                      <a:round/>
-                      <a:headEnd type="none" w="med" len="med"/>
-                      <a:tailEnd type="none" w="med" len="med"/>
-                    </a:lnT>
-                    <a:lnB w="6350" cap="flat" cmpd="sng" algn="ctr">
-                      <a:solidFill>
-                        <a:srgbClr val="D8DDE8"/>
-                      </a:solidFill>
-                      <a:prstDash val="solid"/>
-                      <a:round/>
-                      <a:headEnd type="none" w="med" len="med"/>
-                      <a:tailEnd type="none" w="med" len="med"/>
-                    </a:lnB>
-                  </a:tcPr>
-                </a:tc>
-              </a:tr>
-              <a:tr h="310896">
-                <a:tc>
-                  <a:txBody>
-                    <a:bodyPr/>
-                    <a:lstStyle/>
-                    <a:p>
-                      <a:pPr indent="0" marL="0">
-                        <a:buNone/>
-                      </a:pPr>
-                      <a:r>
-                        <a:rPr lang="en-US" sz="950" dirty="0">
-                          <a:solidFill>
-                            <a:srgbClr val="000000"/>
-                          </a:solidFill>
-                          <a:latin typeface="Calibri" pitchFamily="34" charset="0"/>
-                          <a:ea typeface="Calibri" pitchFamily="34" charset="-122"/>
-                          <a:cs typeface="Calibri" pitchFamily="34" charset="-120"/>
-                        </a:rPr>
-                        <a:t>E2 classical (280)</a:t>
-                      </a:r>
-                      <a:endParaRPr lang="en-US" sz="950" dirty="0">
-                        <a:latin typeface="Calibri" charset="0"/>
-                        <a:ea typeface="Calibri" charset="0"/>
-                        <a:cs typeface="Calibri" charset="0"/>
-                      </a:endParaRPr>
-                    </a:p>
-                  </a:txBody>
-                  <a:tcPr marL="36576" marR="36576" marT="36576" marB="36576" anchor="ctr">
-                    <a:lnL w="6350" cap="flat" cmpd="sng" algn="ctr">
-                      <a:solidFill>
-                        <a:srgbClr val="D8DDE8"/>
-                      </a:solidFill>
-                      <a:prstDash val="solid"/>
-                      <a:round/>
-                      <a:headEnd type="none" w="med" len="med"/>
-                      <a:tailEnd type="none" w="med" len="med"/>
-                    </a:lnL>
-                    <a:lnR w="6350" cap="flat" cmpd="sng" algn="ctr">
-                      <a:solidFill>
-                        <a:srgbClr val="D8DDE8"/>
-                      </a:solidFill>
-                      <a:prstDash val="solid"/>
-                      <a:round/>
-                      <a:headEnd type="none" w="med" len="med"/>
-                      <a:tailEnd type="none" w="med" len="med"/>
-                    </a:lnR>
-                    <a:lnT w="6350" cap="flat" cmpd="sng" algn="ctr">
-                      <a:solidFill>
-                        <a:srgbClr val="D8DDE8"/>
-                      </a:solidFill>
-                      <a:prstDash val="solid"/>
-                      <a:round/>
-                      <a:headEnd type="none" w="med" len="med"/>
-                      <a:tailEnd type="none" w="med" len="med"/>
-                    </a:lnT>
-                    <a:lnB w="6350" cap="flat" cmpd="sng" algn="ctr">
-                      <a:solidFill>
-                        <a:srgbClr val="D8DDE8"/>
-                      </a:solidFill>
-                      <a:prstDash val="solid"/>
-                      <a:round/>
-                      <a:headEnd type="none" w="med" len="med"/>
-                      <a:tailEnd type="none" w="med" len="med"/>
-                    </a:lnB>
-                  </a:tcPr>
-                </a:tc>
-                <a:tc>
-                  <a:txBody>
-                    <a:bodyPr/>
-                    <a:lstStyle/>
-                    <a:p>
-                      <a:pPr indent="0" marL="0">
-                        <a:buNone/>
-                      </a:pPr>
-                      <a:r>
-                        <a:rPr lang="en-US" sz="950" dirty="0">
-                          <a:solidFill>
-                            <a:srgbClr val="000000"/>
-                          </a:solidFill>
-                          <a:latin typeface="Calibri" pitchFamily="34" charset="0"/>
-                          <a:ea typeface="Calibri" pitchFamily="34" charset="-122"/>
-                          <a:cs typeface="Calibri" pitchFamily="34" charset="-120"/>
-                        </a:rPr>
-                        <a:t>280</a:t>
-                      </a:r>
-                      <a:endParaRPr lang="en-US" sz="950" dirty="0">
-                        <a:latin typeface="Calibri" charset="0"/>
-                        <a:ea typeface="Calibri" charset="0"/>
-                        <a:cs typeface="Calibri" charset="0"/>
-                      </a:endParaRPr>
-                    </a:p>
-                  </a:txBody>
-                  <a:tcPr marL="36576" marR="36576" marT="36576" marB="36576" anchor="ctr">
-                    <a:lnL w="6350" cap="flat" cmpd="sng" algn="ctr">
-                      <a:solidFill>
-                        <a:srgbClr val="D8DDE8"/>
-                      </a:solidFill>
-                      <a:prstDash val="solid"/>
-                      <a:round/>
-                      <a:headEnd type="none" w="med" len="med"/>
-                      <a:tailEnd type="none" w="med" len="med"/>
-                    </a:lnL>
-                    <a:lnR w="6350" cap="flat" cmpd="sng" algn="ctr">
-                      <a:solidFill>
-                        <a:srgbClr val="D8DDE8"/>
-                      </a:solidFill>
-                      <a:prstDash val="solid"/>
-                      <a:round/>
-                      <a:headEnd type="none" w="med" len="med"/>
-                      <a:tailEnd type="none" w="med" len="med"/>
-                    </a:lnR>
-                    <a:lnT w="6350" cap="flat" cmpd="sng" algn="ctr">
-                      <a:solidFill>
-                        <a:srgbClr val="D8DDE8"/>
-                      </a:solidFill>
-                      <a:prstDash val="solid"/>
-                      <a:round/>
-                      <a:headEnd type="none" w="med" len="med"/>
-                      <a:tailEnd type="none" w="med" len="med"/>
-                    </a:lnT>
-                    <a:lnB w="6350" cap="flat" cmpd="sng" algn="ctr">
-                      <a:solidFill>
-                        <a:srgbClr val="D8DDE8"/>
-                      </a:solidFill>
-                      <a:prstDash val="solid"/>
-                      <a:round/>
-                      <a:headEnd type="none" w="med" len="med"/>
-                      <a:tailEnd type="none" w="med" len="med"/>
-                    </a:lnB>
-                  </a:tcPr>
-                </a:tc>
-                <a:tc>
-                  <a:txBody>
-                    <a:bodyPr/>
-                    <a:lstStyle/>
-                    <a:p>
-                      <a:pPr indent="0" marL="0">
-                        <a:buNone/>
-                      </a:pPr>
-                      <a:r>
-                        <a:rPr lang="en-US" sz="950" b="1" dirty="0">
-                          <a:solidFill>
-                            <a:srgbClr val="2C5F2D"/>
-                          </a:solidFill>
-                          <a:latin typeface="Calibri" pitchFamily="34" charset="0"/>
-                          <a:ea typeface="Calibri" pitchFamily="34" charset="-122"/>
-                          <a:cs typeface="Calibri" pitchFamily="34" charset="-120"/>
-                        </a:rPr>
-                        <a:t>complete</a:t>
-                      </a:r>
-                      <a:endParaRPr lang="en-US" sz="950" dirty="0">
-                        <a:latin typeface="Calibri" charset="0"/>
-                        <a:ea typeface="Calibri" charset="0"/>
-                        <a:cs typeface="Calibri" charset="0"/>
-                      </a:endParaRPr>
-                    </a:p>
-                  </a:txBody>
-                  <a:tcPr marL="36576" marR="36576" marT="36576" marB="36576" anchor="ctr">
-                    <a:lnL w="6350" cap="flat" cmpd="sng" algn="ctr">
-                      <a:solidFill>
-                        <a:srgbClr val="D8DDE8"/>
-                      </a:solidFill>
-                      <a:prstDash val="solid"/>
-                      <a:round/>
-                      <a:headEnd type="none" w="med" len="med"/>
-                      <a:tailEnd type="none" w="med" len="med"/>
-                    </a:lnL>
-                    <a:lnR w="6350" cap="flat" cmpd="sng" algn="ctr">
-                      <a:solidFill>
-                        <a:srgbClr val="D8DDE8"/>
-                      </a:solidFill>
-                      <a:prstDash val="solid"/>
-                      <a:round/>
-                      <a:headEnd type="none" w="med" len="med"/>
-                      <a:tailEnd type="none" w="med" len="med"/>
-                    </a:lnR>
-                    <a:lnT w="6350" cap="flat" cmpd="sng" algn="ctr">
-                      <a:solidFill>
-                        <a:srgbClr val="D8DDE8"/>
-                      </a:solidFill>
-                      <a:prstDash val="solid"/>
-                      <a:round/>
-                      <a:headEnd type="none" w="med" len="med"/>
-                      <a:tailEnd type="none" w="med" len="med"/>
-                    </a:lnT>
-                    <a:lnB w="6350" cap="flat" cmpd="sng" algn="ctr">
-                      <a:solidFill>
-                        <a:srgbClr val="D8DDE8"/>
-                      </a:solidFill>
-                      <a:prstDash val="solid"/>
-                      <a:round/>
-                      <a:headEnd type="none" w="med" len="med"/>
-                      <a:tailEnd type="none" w="med" len="med"/>
-                    </a:lnB>
-                  </a:tcPr>
-                </a:tc>
-              </a:tr>
-              <a:tr h="310896">
-                <a:tc>
-                  <a:txBody>
-                    <a:bodyPr/>
-                    <a:lstStyle/>
-                    <a:p>
-                      <a:pPr indent="0" marL="0">
-                        <a:buNone/>
-                      </a:pPr>
-                      <a:r>
-                        <a:rPr lang="en-US" sz="950" dirty="0">
-                          <a:solidFill>
-                            <a:srgbClr val="000000"/>
-                          </a:solidFill>
-                          <a:latin typeface="Calibri" pitchFamily="34" charset="0"/>
-                          <a:ea typeface="Calibri" pitchFamily="34" charset="-122"/>
-                          <a:cs typeface="Calibri" pitchFamily="34" charset="-120"/>
-                        </a:rPr>
-                        <a:t>E3 classical (120)</a:t>
-                      </a:r>
-                      <a:endParaRPr lang="en-US" sz="950" dirty="0">
-                        <a:latin typeface="Calibri" charset="0"/>
-                        <a:ea typeface="Calibri" charset="0"/>
-                        <a:cs typeface="Calibri" charset="0"/>
-                      </a:endParaRPr>
-                    </a:p>
-                  </a:txBody>
-                  <a:tcPr marL="36576" marR="36576" marT="36576" marB="36576" anchor="ctr">
-                    <a:lnL w="6350" cap="flat" cmpd="sng" algn="ctr">
-                      <a:solidFill>
-                        <a:srgbClr val="D8DDE8"/>
-                      </a:solidFill>
-                      <a:prstDash val="solid"/>
-                      <a:round/>
-                      <a:headEnd type="none" w="med" len="med"/>
-                      <a:tailEnd type="none" w="med" len="med"/>
-                    </a:lnL>
-                    <a:lnR w="6350" cap="flat" cmpd="sng" algn="ctr">
-                      <a:solidFill>
-                        <a:srgbClr val="D8DDE8"/>
-                      </a:solidFill>
-                      <a:prstDash val="solid"/>
-                      <a:round/>
-                      <a:headEnd type="none" w="med" len="med"/>
-                      <a:tailEnd type="none" w="med" len="med"/>
-                    </a:lnR>
-                    <a:lnT w="6350" cap="flat" cmpd="sng" algn="ctr">
-                      <a:solidFill>
-                        <a:srgbClr val="D8DDE8"/>
-                      </a:solidFill>
-                      <a:prstDash val="solid"/>
-                      <a:round/>
-                      <a:headEnd type="none" w="med" len="med"/>
-                      <a:tailEnd type="none" w="med" len="med"/>
-                    </a:lnT>
-                    <a:lnB w="6350" cap="flat" cmpd="sng" algn="ctr">
-                      <a:solidFill>
-                        <a:srgbClr val="D8DDE8"/>
-                      </a:solidFill>
-                      <a:prstDash val="solid"/>
-                      <a:round/>
-                      <a:headEnd type="none" w="med" len="med"/>
-                      <a:tailEnd type="none" w="med" len="med"/>
-                    </a:lnB>
-                  </a:tcPr>
-                </a:tc>
-                <a:tc>
-                  <a:txBody>
-                    <a:bodyPr/>
-                    <a:lstStyle/>
-                    <a:p>
-                      <a:pPr indent="0" marL="0">
-                        <a:buNone/>
-                      </a:pPr>
-                      <a:r>
-                        <a:rPr lang="en-US" sz="950" dirty="0">
-                          <a:solidFill>
-                            <a:srgbClr val="000000"/>
-                          </a:solidFill>
-                          <a:latin typeface="Calibri" pitchFamily="34" charset="0"/>
-                          <a:ea typeface="Calibri" pitchFamily="34" charset="-122"/>
-                          <a:cs typeface="Calibri" pitchFamily="34" charset="-120"/>
-                        </a:rPr>
-                        <a:t>running</a:t>
-                      </a:r>
-                      <a:endParaRPr lang="en-US" sz="950" dirty="0">
-                        <a:latin typeface="Calibri" charset="0"/>
-                        <a:ea typeface="Calibri" charset="0"/>
-                        <a:cs typeface="Calibri" charset="0"/>
-                      </a:endParaRPr>
-                    </a:p>
-                  </a:txBody>
-                  <a:tcPr marL="36576" marR="36576" marT="36576" marB="36576" anchor="ctr">
-                    <a:lnL w="6350" cap="flat" cmpd="sng" algn="ctr">
-                      <a:solidFill>
-                        <a:srgbClr val="D8DDE8"/>
-                      </a:solidFill>
-                      <a:prstDash val="solid"/>
-                      <a:round/>
-                      <a:headEnd type="none" w="med" len="med"/>
-                      <a:tailEnd type="none" w="med" len="med"/>
-                    </a:lnL>
-                    <a:lnR w="6350" cap="flat" cmpd="sng" algn="ctr">
-                      <a:solidFill>
-                        <a:srgbClr val="D8DDE8"/>
-                      </a:solidFill>
-                      <a:prstDash val="solid"/>
-                      <a:round/>
-                      <a:headEnd type="none" w="med" len="med"/>
-                      <a:tailEnd type="none" w="med" len="med"/>
-                    </a:lnR>
-                    <a:lnT w="6350" cap="flat" cmpd="sng" algn="ctr">
-                      <a:solidFill>
-                        <a:srgbClr val="D8DDE8"/>
-                      </a:solidFill>
-                      <a:prstDash val="solid"/>
-                      <a:round/>
-                      <a:headEnd type="none" w="med" len="med"/>
-                      <a:tailEnd type="none" w="med" len="med"/>
-                    </a:lnT>
-                    <a:lnB w="6350" cap="flat" cmpd="sng" algn="ctr">
-                      <a:solidFill>
-                        <a:srgbClr val="D8DDE8"/>
-                      </a:solidFill>
-                      <a:prstDash val="solid"/>
-                      <a:round/>
-                      <a:headEnd type="none" w="med" len="med"/>
-                      <a:tailEnd type="none" w="med" len="med"/>
-                    </a:lnB>
-                  </a:tcPr>
-                </a:tc>
-                <a:tc>
-                  <a:txBody>
-                    <a:bodyPr/>
-                    <a:lstStyle/>
-                    <a:p>
-                      <a:pPr indent="0" marL="0">
-                        <a:buNone/>
-                      </a:pPr>
-                      <a:r>
-                        <a:rPr lang="en-US" sz="950" b="1" dirty="0">
-                          <a:solidFill>
-                            <a:srgbClr val="B8860B"/>
-                          </a:solidFill>
-                          <a:latin typeface="Calibri" pitchFamily="34" charset="0"/>
-                          <a:ea typeface="Calibri" pitchFamily="34" charset="-122"/>
-                          <a:cs typeface="Calibri" pitchFamily="34" charset="-120"/>
-                        </a:rPr>
-                        <a:t>running</a:t>
-                      </a:r>
-                      <a:endParaRPr lang="en-US" sz="950" dirty="0">
-                        <a:latin typeface="Calibri" charset="0"/>
-                        <a:ea typeface="Calibri" charset="0"/>
-                        <a:cs typeface="Calibri" charset="0"/>
-                      </a:endParaRPr>
-                    </a:p>
-                  </a:txBody>
-                  <a:tcPr marL="36576" marR="36576" marT="36576" marB="36576" anchor="ctr">
-                    <a:lnL w="6350" cap="flat" cmpd="sng" algn="ctr">
-                      <a:solidFill>
-                        <a:srgbClr val="D8DDE8"/>
-                      </a:solidFill>
-                      <a:prstDash val="solid"/>
-                      <a:round/>
-                      <a:headEnd type="none" w="med" len="med"/>
-                      <a:tailEnd type="none" w="med" len="med"/>
-                    </a:lnL>
-                    <a:lnR w="6350" cap="flat" cmpd="sng" algn="ctr">
-                      <a:solidFill>
-                        <a:srgbClr val="D8DDE8"/>
-                      </a:solidFill>
-                      <a:prstDash val="solid"/>
-                      <a:round/>
-                      <a:headEnd type="none" w="med" len="med"/>
-                      <a:tailEnd type="none" w="med" len="med"/>
-                    </a:lnR>
-                    <a:lnT w="6350" cap="flat" cmpd="sng" algn="ctr">
-                      <a:solidFill>
-                        <a:srgbClr val="D8DDE8"/>
-                      </a:solidFill>
-                      <a:prstDash val="solid"/>
-                      <a:round/>
-                      <a:headEnd type="none" w="med" len="med"/>
-                      <a:tailEnd type="none" w="med" len="med"/>
-                    </a:lnT>
-                    <a:lnB w="6350" cap="flat" cmpd="sng" algn="ctr">
-                      <a:solidFill>
-                        <a:srgbClr val="D8DDE8"/>
-                      </a:solidFill>
-                      <a:prstDash val="solid"/>
-                      <a:round/>
-                      <a:headEnd type="none" w="med" len="med"/>
-                      <a:tailEnd type="none" w="med" len="med"/>
-                    </a:lnB>
-                  </a:tcPr>
-                </a:tc>
-              </a:tr>
-              <a:tr h="310896">
-                <a:tc>
-                  <a:txBody>
-                    <a:bodyPr/>
-                    <a:lstStyle/>
-                    <a:p>
-                      <a:pPr indent="0" marL="0">
-                        <a:buNone/>
-                      </a:pPr>
-                      <a:r>
-                        <a:rPr lang="en-US" sz="950" dirty="0">
-                          <a:solidFill>
-                            <a:srgbClr val="000000"/>
-                          </a:solidFill>
-                          <a:latin typeface="Calibri" pitchFamily="34" charset="0"/>
-                          <a:ea typeface="Calibri" pitchFamily="34" charset="-122"/>
-                          <a:cs typeface="Calibri" pitchFamily="34" charset="-120"/>
-                        </a:rPr>
-                        <a:t>LLM cells (220)</a:t>
-                      </a:r>
-                      <a:endParaRPr lang="en-US" sz="950" dirty="0">
-                        <a:latin typeface="Calibri" charset="0"/>
-                        <a:ea typeface="Calibri" charset="0"/>
-                        <a:cs typeface="Calibri" charset="0"/>
-                      </a:endParaRPr>
-                    </a:p>
-                  </a:txBody>
-                  <a:tcPr marL="36576" marR="36576" marT="36576" marB="36576" anchor="ctr">
-                    <a:lnL w="6350" cap="flat" cmpd="sng" algn="ctr">
-                      <a:solidFill>
-                        <a:srgbClr val="D8DDE8"/>
-                      </a:solidFill>
-                      <a:prstDash val="solid"/>
-                      <a:round/>
-                      <a:headEnd type="none" w="med" len="med"/>
-                      <a:tailEnd type="none" w="med" len="med"/>
-                    </a:lnL>
-                    <a:lnR w="6350" cap="flat" cmpd="sng" algn="ctr">
-                      <a:solidFill>
-                        <a:srgbClr val="D8DDE8"/>
-                      </a:solidFill>
-                      <a:prstDash val="solid"/>
-                      <a:round/>
-                      <a:headEnd type="none" w="med" len="med"/>
-                      <a:tailEnd type="none" w="med" len="med"/>
-                    </a:lnR>
-                    <a:lnT w="6350" cap="flat" cmpd="sng" algn="ctr">
-                      <a:solidFill>
-                        <a:srgbClr val="D8DDE8"/>
-                      </a:solidFill>
-                      <a:prstDash val="solid"/>
-                      <a:round/>
-                      <a:headEnd type="none" w="med" len="med"/>
-                      <a:tailEnd type="none" w="med" len="med"/>
-                    </a:lnT>
-                    <a:lnB w="6350" cap="flat" cmpd="sng" algn="ctr">
-                      <a:solidFill>
-                        <a:srgbClr val="D8DDE8"/>
-                      </a:solidFill>
-                      <a:prstDash val="solid"/>
-                      <a:round/>
-                      <a:headEnd type="none" w="med" len="med"/>
-                      <a:tailEnd type="none" w="med" len="med"/>
-                    </a:lnB>
-                  </a:tcPr>
-                </a:tc>
-                <a:tc>
-                  <a:txBody>
-                    <a:bodyPr/>
-                    <a:lstStyle/>
-                    <a:p>
-                      <a:pPr indent="0" marL="0">
-                        <a:buNone/>
-                      </a:pPr>
-                      <a:r>
-                        <a:rPr lang="en-US" sz="950" dirty="0">
-                          <a:solidFill>
-                            <a:srgbClr val="000000"/>
-                          </a:solidFill>
-                          <a:latin typeface="Calibri" pitchFamily="34" charset="0"/>
-                          <a:ea typeface="Calibri" pitchFamily="34" charset="-122"/>
-                          <a:cs typeface="Calibri" pitchFamily="34" charset="-120"/>
-                        </a:rPr>
-                        <a:t>0</a:t>
-                      </a:r>
-                      <a:endParaRPr lang="en-US" sz="950" dirty="0">
-                        <a:latin typeface="Calibri" charset="0"/>
-                        <a:ea typeface="Calibri" charset="0"/>
-                        <a:cs typeface="Calibri" charset="0"/>
-                      </a:endParaRPr>
-                    </a:p>
-                  </a:txBody>
-                  <a:tcPr marL="36576" marR="36576" marT="36576" marB="36576" anchor="ctr">
-                    <a:lnL w="6350" cap="flat" cmpd="sng" algn="ctr">
-                      <a:solidFill>
-                        <a:srgbClr val="D8DDE8"/>
-                      </a:solidFill>
-                      <a:prstDash val="solid"/>
-                      <a:round/>
-                      <a:headEnd type="none" w="med" len="med"/>
-                      <a:tailEnd type="none" w="med" len="med"/>
-                    </a:lnL>
-                    <a:lnR w="6350" cap="flat" cmpd="sng" algn="ctr">
-                      <a:solidFill>
-                        <a:srgbClr val="D8DDE8"/>
-                      </a:solidFill>
-                      <a:prstDash val="solid"/>
-                      <a:round/>
-                      <a:headEnd type="none" w="med" len="med"/>
-                      <a:tailEnd type="none" w="med" len="med"/>
-                    </a:lnR>
-                    <a:lnT w="6350" cap="flat" cmpd="sng" algn="ctr">
-                      <a:solidFill>
-                        <a:srgbClr val="D8DDE8"/>
-                      </a:solidFill>
-                      <a:prstDash val="solid"/>
-                      <a:round/>
-                      <a:headEnd type="none" w="med" len="med"/>
-                      <a:tailEnd type="none" w="med" len="med"/>
-                    </a:lnT>
-                    <a:lnB w="6350" cap="flat" cmpd="sng" algn="ctr">
-                      <a:solidFill>
-                        <a:srgbClr val="D8DDE8"/>
-                      </a:solidFill>
-                      <a:prstDash val="solid"/>
-                      <a:round/>
-                      <a:headEnd type="none" w="med" len="med"/>
-                      <a:tailEnd type="none" w="med" len="med"/>
-                    </a:lnB>
-                  </a:tcPr>
-                </a:tc>
-                <a:tc>
-                  <a:txBody>
-                    <a:bodyPr/>
-                    <a:lstStyle/>
-                    <a:p>
-                      <a:pPr indent="0" marL="0">
-                        <a:buNone/>
-                      </a:pPr>
-                      <a:r>
-                        <a:rPr lang="en-US" sz="950" b="1" dirty="0">
-                          <a:solidFill>
-                            <a:srgbClr val="C44E52"/>
-                          </a:solidFill>
-                          <a:latin typeface="Calibri" pitchFamily="34" charset="0"/>
-                          <a:ea typeface="Calibri" pitchFamily="34" charset="-122"/>
-                          <a:cs typeface="Calibri" pitchFamily="34" charset="-120"/>
-                        </a:rPr>
-                        <a:t>blocked*</a:t>
-                      </a:r>
-                      <a:endParaRPr lang="en-US" sz="950" dirty="0">
-                        <a:latin typeface="Calibri" charset="0"/>
-                        <a:ea typeface="Calibri" charset="0"/>
-                        <a:cs typeface="Calibri" charset="0"/>
-                      </a:endParaRPr>
-                    </a:p>
-                  </a:txBody>
-                  <a:tcPr marL="36576" marR="36576" marT="36576" marB="36576" anchor="ctr">
-                    <a:lnL w="6350" cap="flat" cmpd="sng" algn="ctr">
-                      <a:solidFill>
-                        <a:srgbClr val="D8DDE8"/>
-                      </a:solidFill>
-                      <a:prstDash val="solid"/>
-                      <a:round/>
-                      <a:headEnd type="none" w="med" len="med"/>
-                      <a:tailEnd type="none" w="med" len="med"/>
-                    </a:lnL>
-                    <a:lnR w="6350" cap="flat" cmpd="sng" algn="ctr">
-                      <a:solidFill>
-                        <a:srgbClr val="D8DDE8"/>
-                      </a:solidFill>
-                      <a:prstDash val="solid"/>
-                      <a:round/>
-                      <a:headEnd type="none" w="med" len="med"/>
-                      <a:tailEnd type="none" w="med" len="med"/>
-                    </a:lnR>
-                    <a:lnT w="6350" cap="flat" cmpd="sng" algn="ctr">
-                      <a:solidFill>
-                        <a:srgbClr val="D8DDE8"/>
-                      </a:solidFill>
-                      <a:prstDash val="solid"/>
-                      <a:round/>
-                      <a:headEnd type="none" w="med" len="med"/>
-                      <a:tailEnd type="none" w="med" len="med"/>
-                    </a:lnT>
-                    <a:lnB w="6350" cap="flat" cmpd="sng" algn="ctr">
-                      <a:solidFill>
-                        <a:srgbClr val="D8DDE8"/>
-                      </a:solidFill>
-                      <a:prstDash val="solid"/>
-                      <a:round/>
-                      <a:headEnd type="none" w="med" len="med"/>
-                      <a:tailEnd type="none" w="med" len="med"/>
-                    </a:lnB>
-                  </a:tcPr>
-                </a:tc>
-              </a:tr>
-              <a:tr h="310896">
-                <a:tc>
-                  <a:txBody>
-                    <a:bodyPr/>
-                    <a:lstStyle/>
-                    <a:p>
-                      <a:pPr indent="0" marL="0">
-                        <a:buNone/>
-                      </a:pPr>
-                      <a:r>
-                        <a:rPr lang="en-US" sz="950" dirty="0">
-                          <a:solidFill>
-                            <a:srgbClr val="000000"/>
-                          </a:solidFill>
-                          <a:latin typeface="Calibri" pitchFamily="34" charset="0"/>
-                          <a:ea typeface="Calibri" pitchFamily="34" charset="-122"/>
-                          <a:cs typeface="Calibri" pitchFamily="34" charset="-120"/>
-                        </a:rPr>
-                        <a:t>E4 / E5</a:t>
-                      </a:r>
-                      <a:endParaRPr lang="en-US" sz="950" dirty="0">
-                        <a:latin typeface="Calibri" charset="0"/>
-                        <a:ea typeface="Calibri" charset="0"/>
-                        <a:cs typeface="Calibri" charset="0"/>
-                      </a:endParaRPr>
-                    </a:p>
-                  </a:txBody>
-                  <a:tcPr marL="36576" marR="36576" marT="36576" marB="36576" anchor="ctr">
-                    <a:lnL w="6350" cap="flat" cmpd="sng" algn="ctr">
-                      <a:solidFill>
-                        <a:srgbClr val="D8DDE8"/>
-                      </a:solidFill>
-                      <a:prstDash val="solid"/>
-                      <a:round/>
-                      <a:headEnd type="none" w="med" len="med"/>
-                      <a:tailEnd type="none" w="med" len="med"/>
-                    </a:lnL>
-                    <a:lnR w="6350" cap="flat" cmpd="sng" algn="ctr">
-                      <a:solidFill>
-                        <a:srgbClr val="D8DDE8"/>
-                      </a:solidFill>
-                      <a:prstDash val="solid"/>
-                      <a:round/>
-                      <a:headEnd type="none" w="med" len="med"/>
-                      <a:tailEnd type="none" w="med" len="med"/>
-                    </a:lnR>
-                    <a:lnT w="6350" cap="flat" cmpd="sng" algn="ctr">
-                      <a:solidFill>
-                        <a:srgbClr val="D8DDE8"/>
-                      </a:solidFill>
-                      <a:prstDash val="solid"/>
-                      <a:round/>
-                      <a:headEnd type="none" w="med" len="med"/>
-                      <a:tailEnd type="none" w="med" len="med"/>
-                    </a:lnT>
-                    <a:lnB w="6350" cap="flat" cmpd="sng" algn="ctr">
-                      <a:solidFill>
-                        <a:srgbClr val="D8DDE8"/>
-                      </a:solidFill>
-                      <a:prstDash val="solid"/>
-                      <a:round/>
-                      <a:headEnd type="none" w="med" len="med"/>
-                      <a:tailEnd type="none" w="med" len="med"/>
-                    </a:lnB>
-                  </a:tcPr>
-                </a:tc>
-                <a:tc>
-                  <a:txBody>
-                    <a:bodyPr/>
-                    <a:lstStyle/>
-                    <a:p>
-                      <a:pPr indent="0" marL="0">
-                        <a:buNone/>
-                      </a:pPr>
-                      <a:r>
-                        <a:rPr lang="en-US" sz="950" dirty="0">
-                          <a:solidFill>
-                            <a:srgbClr val="000000"/>
-                          </a:solidFill>
-                          <a:latin typeface="Calibri" pitchFamily="34" charset="0"/>
-                          <a:ea typeface="Calibri" pitchFamily="34" charset="-122"/>
-                          <a:cs typeface="Calibri" pitchFamily="34" charset="-120"/>
-                        </a:rPr>
-                        <a:t>—</a:t>
-                      </a:r>
-                      <a:endParaRPr lang="en-US" sz="950" dirty="0">
-                        <a:latin typeface="Calibri" charset="0"/>
-                        <a:ea typeface="Calibri" charset="0"/>
-                        <a:cs typeface="Calibri" charset="0"/>
-                      </a:endParaRPr>
-                    </a:p>
-                  </a:txBody>
-                  <a:tcPr marL="36576" marR="36576" marT="36576" marB="36576" anchor="ctr">
-                    <a:lnL w="6350" cap="flat" cmpd="sng" algn="ctr">
-                      <a:solidFill>
-                        <a:srgbClr val="D8DDE8"/>
-                      </a:solidFill>
-                      <a:prstDash val="solid"/>
-                      <a:round/>
-                      <a:headEnd type="none" w="med" len="med"/>
-                      <a:tailEnd type="none" w="med" len="med"/>
-                    </a:lnL>
-                    <a:lnR w="6350" cap="flat" cmpd="sng" algn="ctr">
-                      <a:solidFill>
-                        <a:srgbClr val="D8DDE8"/>
-                      </a:solidFill>
-                      <a:prstDash val="solid"/>
-                      <a:round/>
-                      <a:headEnd type="none" w="med" len="med"/>
-                      <a:tailEnd type="none" w="med" len="med"/>
-                    </a:lnR>
-                    <a:lnT w="6350" cap="flat" cmpd="sng" algn="ctr">
-                      <a:solidFill>
-                        <a:srgbClr val="D8DDE8"/>
-                      </a:solidFill>
-                      <a:prstDash val="solid"/>
-                      <a:round/>
-                      <a:headEnd type="none" w="med" len="med"/>
-                      <a:tailEnd type="none" w="med" len="med"/>
-                    </a:lnT>
-                    <a:lnB w="6350" cap="flat" cmpd="sng" algn="ctr">
-                      <a:solidFill>
-                        <a:srgbClr val="D8DDE8"/>
-                      </a:solidFill>
-                      <a:prstDash val="solid"/>
-                      <a:round/>
-                      <a:headEnd type="none" w="med" len="med"/>
-                      <a:tailEnd type="none" w="med" len="med"/>
-                    </a:lnB>
-                  </a:tcPr>
-                </a:tc>
-                <a:tc>
-                  <a:txBody>
-                    <a:bodyPr/>
-                    <a:lstStyle/>
-                    <a:p>
-                      <a:pPr indent="0" marL="0">
-                        <a:buNone/>
-                      </a:pPr>
-                      <a:r>
-                        <a:rPr lang="en-US" sz="950" b="1" dirty="0">
-                          <a:solidFill>
-                            <a:srgbClr val="5A5A6E"/>
-                          </a:solidFill>
-                          <a:latin typeface="Calibri" pitchFamily="34" charset="0"/>
-                          <a:ea typeface="Calibri" pitchFamily="34" charset="-122"/>
-                          <a:cs typeface="Calibri" pitchFamily="34" charset="-120"/>
-                        </a:rPr>
-                        <a:t>pending</a:t>
-                      </a:r>
-                      <a:endParaRPr lang="en-US" sz="950" dirty="0">
-                        <a:latin typeface="Calibri" charset="0"/>
-                        <a:ea typeface="Calibri" charset="0"/>
-                        <a:cs typeface="Calibri" charset="0"/>
-                      </a:endParaRPr>
-                    </a:p>
-                  </a:txBody>
-                  <a:tcPr marL="36576" marR="36576" marT="36576" marB="36576" anchor="ctr">
-                    <a:lnL w="6350" cap="flat" cmpd="sng" algn="ctr">
-                      <a:solidFill>
-                        <a:srgbClr val="D8DDE8"/>
-                      </a:solidFill>
-                      <a:prstDash val="solid"/>
-                      <a:round/>
-                      <a:headEnd type="none" w="med" len="med"/>
-                      <a:tailEnd type="none" w="med" len="med"/>
-                    </a:lnL>
-                    <a:lnR w="6350" cap="flat" cmpd="sng" algn="ctr">
-                      <a:solidFill>
-                        <a:srgbClr val="D8DDE8"/>
-                      </a:solidFill>
-                      <a:prstDash val="solid"/>
-                      <a:round/>
-                      <a:headEnd type="none" w="med" len="med"/>
-                      <a:tailEnd type="none" w="med" len="med"/>
-                    </a:lnR>
-                    <a:lnT w="6350" cap="flat" cmpd="sng" algn="ctr">
-                      <a:solidFill>
-                        <a:srgbClr val="D8DDE8"/>
-                      </a:solidFill>
-                      <a:prstDash val="solid"/>
-                      <a:round/>
-                      <a:headEnd type="none" w="med" len="med"/>
-                      <a:tailEnd type="none" w="med" len="med"/>
-                    </a:lnT>
-                    <a:lnB w="6350" cap="flat" cmpd="sng" algn="ctr">
-                      <a:solidFill>
-                        <a:srgbClr val="D8DDE8"/>
-                      </a:solidFill>
-                      <a:prstDash val="solid"/>
-                      <a:round/>
-                      <a:headEnd type="none" w="med" len="med"/>
-                      <a:tailEnd type="none" w="med" len="med"/>
-                    </a:lnB>
-                  </a:tcPr>
-                </a:tc>
-              </a:tr>
-            </a:tbl>
-          </a:graphicData>
-        </a:graphic>
-      </p:graphicFrame>
-      <p:sp>
-        <p:nvSpPr>
-          <p:cNvPr id="7" name="Text 2"/>
-          <p:cNvSpPr/>
-          <p:nvPr/>
-        </p:nvSpPr>
-        <p:spPr>
-          <a:xfrm>
-            <a:off x="9144000" y="3429000"/>
-            <a:ext cx="2651760" cy="2651760"/>
+      <p:pic>
+        <p:nvPicPr>
+          <p:cNvPr id="6" name="Image 2" descr="/Users/hatanakatomoya/Developer/Sim/llm-vqc/.claude/worktrees/github-author-config-faee6e/docs/presentation/bench_v2_weekly/figures/fig_e3_scaling.png">    </p:cNvPr>
+          <p:cNvPicPr>
+            <a:picLocks noChangeAspect="1"/>
+          </p:cNvPicPr>
+          <p:nvPr/>
+        </p:nvPicPr>
+        <p:blipFill>
+          <a:blip r:embed="rId3"/>
+          <a:stretch>
+            <a:fillRect/>
+          </a:stretch>
+        </p:blipFill>
+        <p:spPr>
+          <a:xfrm>
+            <a:off x="7863840" y="1325880"/>
+            <a:ext cx="3931920" cy="1609344"/>
+          </a:xfrm>
+          <a:prstGeom prst="rect">
+            <a:avLst/>
+          </a:prstGeom>
+        </p:spPr>
+      </p:pic>
+      <p:sp>
+        <p:nvSpPr>
+          <p:cNvPr id="7" name="Shape 2"/>
+          <p:cNvSpPr/>
+          <p:nvPr/>
+        </p:nvSpPr>
+        <p:spPr>
+          <a:xfrm>
+            <a:off x="457200" y="4983480"/>
+            <a:ext cx="7178040" cy="566928"/>
+          </a:xfrm>
+          <a:prstGeom prst="roundRect">
+            <a:avLst>
+              <a:gd name="adj" fmla="val 12903"/>
+            </a:avLst>
+          </a:prstGeom>
+          <a:solidFill>
+            <a:srgbClr val="CADCFC">
+              <a:alpha val="45000"/>
+            </a:srgbClr>
+          </a:solidFill>
+          <a:ln w="9525">
+            <a:solidFill>
+              <a:srgbClr val="D8DDE8"/>
+            </a:solidFill>
+            <a:prstDash val="solid"/>
+          </a:ln>
+        </p:spPr>
+      </p:sp>
+      <p:sp>
+        <p:nvSpPr>
+          <p:cNvPr id="8" name="Text 3"/>
+          <p:cNvSpPr/>
+          <p:nvPr/>
+        </p:nvSpPr>
+        <p:spPr>
+          <a:xfrm>
+            <a:off x="640080" y="5029200"/>
+            <a:ext cx="6858000" cy="475488"/>
           </a:xfrm>
           <a:prstGeom prst="rect">
             <a:avLst/>
@@ -8275,13 +7106,94 @@
           <a:lstStyle/>
           <a:p>
             <a:pPr indent="0" marL="0">
+              <a:buNone/>
+            </a:pPr>
+            <a:r>
+              <a:rPr lang="en-US" sz="1050" b="1" dirty="0">
+                <a:solidFill>
+                  <a:srgbClr val="2C5F2D"/>
+                </a:solidFill>
+                <a:latin typeface="Calibri" pitchFamily="34" charset="0"/>
+                <a:ea typeface="Calibri" pitchFamily="34" charset="-122"/>
+                <a:cs typeface="Calibri" pitchFamily="34" charset="-120"/>
+              </a:rPr>
+              <a:t>460 / 460 classical cells complete, 0 failures</a:t>
+            </a:r>
+            <a:pPr indent="0" marL="0">
+              <a:buNone/>
+            </a:pPr>
+            <a:r>
+              <a:rPr lang="en-US" sz="1000" dirty="0">
+                <a:solidFill>
+                  <a:srgbClr val="5A5A6E"/>
+                </a:solidFill>
+                <a:latin typeface="Calibri" pitchFamily="34" charset="0"/>
+                <a:ea typeface="Calibri" pitchFamily="34" charset="-122"/>
+                <a:cs typeface="Calibri" pitchFamily="34" charset="-120"/>
+              </a:rPr>
+              <a:t>   (E1 60 · E2 280 · E3 120)   |   </a:t>
+            </a:r>
+            <a:pPr indent="0" marL="0">
+              <a:buNone/>
+            </a:pPr>
+            <a:r>
+              <a:rPr lang="en-US" sz="1050" b="1" dirty="0">
+                <a:solidFill>
+                  <a:srgbClr val="C44E52"/>
+                </a:solidFill>
+                <a:latin typeface="Calibri" pitchFamily="34" charset="0"/>
+                <a:ea typeface="Calibri" pitchFamily="34" charset="-122"/>
+                <a:cs typeface="Calibri" pitchFamily="34" charset="-120"/>
+              </a:rPr>
+              <a:t>LLM 0 / 220 blocked</a:t>
+            </a:r>
+            <a:pPr indent="0" marL="0">
+              <a:buNone/>
+            </a:pPr>
+            <a:r>
+              <a:rPr lang="en-US" sz="1000" dirty="0">
+                <a:solidFill>
+                  <a:srgbClr val="5A5A6E"/>
+                </a:solidFill>
+                <a:latin typeface="Calibri" pitchFamily="34" charset="0"/>
+                <a:ea typeface="Calibri" pitchFamily="34" charset="-122"/>
+                <a:cs typeface="Calibri" pitchFamily="34" charset="-120"/>
+              </a:rPr>
+              <a:t>   |   E4 / E5 pending</a:t>
+            </a:r>
+            <a:endParaRPr lang="en-US" sz="1050" dirty="0"/>
+          </a:p>
+        </p:txBody>
+      </p:sp>
+      <p:sp>
+        <p:nvSpPr>
+          <p:cNvPr id="9" name="Text 4"/>
+          <p:cNvSpPr/>
+          <p:nvPr/>
+        </p:nvSpPr>
+        <p:spPr>
+          <a:xfrm>
+            <a:off x="7863840" y="3108960"/>
+            <a:ext cx="3977640" cy="2468880"/>
+          </a:xfrm>
+          <a:prstGeom prst="rect">
+            <a:avLst/>
+          </a:prstGeom>
+          <a:noFill/>
+          <a:ln/>
+        </p:spPr>
+        <p:txBody>
+          <a:bodyPr wrap="square" lIns="0" tIns="0" rIns="0" bIns="0" rtlCol="0" anchor="t"/>
+          <a:lstStyle/>
+          <a:p>
+            <a:pPr indent="0" marL="0">
               <a:spcAft>
-                <a:spcPts val="400"/>
+                <a:spcPts val="500"/>
               </a:spcAft>
               <a:buNone/>
             </a:pPr>
             <a:r>
-              <a:rPr lang="en-US" sz="1050" b="1" dirty="0">
+              <a:rPr lang="en-US" sz="1100" b="1" dirty="0">
                 <a:solidFill>
                   <a:srgbClr val="1A1A2E"/>
                 </a:solidFill>
@@ -8289,14 +7201,14 @@
                 <a:ea typeface="Calibri" pitchFamily="34" charset="-122"/>
                 <a:cs typeface="Calibri" pitchFamily="34" charset="-120"/>
               </a:rPr>
-              <a:t>Findings (10 paired reps, Holm-corrected):</a:t>
-            </a:r>
-            <a:endParaRPr lang="en-US" sz="1050" dirty="0"/>
+              <a:t>Findings</a:t>
+            </a:r>
+            <a:endParaRPr lang="en-US" sz="1100" dirty="0"/>
           </a:p>
           <a:p>
             <a:pPr marL="342900" indent="-342900">
               <a:spcAft>
-                <a:spcPts val="400"/>
+                <a:spcPts val="500"/>
               </a:spcAft>
               <a:buSzPct val="100000"/>
               <a:buChar char="•"/>
@@ -8310,14 +7222,14 @@
                 <a:ea typeface="Calibri" pitchFamily="34" charset="-122"/>
                 <a:cs typeface="Calibri" pitchFamily="34" charset="-120"/>
               </a:rPr>
-              <a:t>Searched circuits beat shallow references on the regression tasks (T1: random vs StrongEnt-d2, p_Holm = 0.032).</a:t>
-            </a:r>
-            <a:endParaRPr lang="en-US" sz="1050" dirty="0"/>
+              <a:t>n=5, 10 paired reps: searched circuits beat the shallow reference on regression tasks (T1 random vs StrongEnt-d2, p_Holm = 0.032).</a:t>
+            </a:r>
+            <a:endParaRPr lang="en-US" sz="1100" dirty="0"/>
           </a:p>
           <a:p>
             <a:pPr marL="342900" indent="-342900">
               <a:spcAft>
-                <a:spcPts val="400"/>
+                <a:spcPts val="500"/>
               </a:spcAft>
               <a:buSzPct val="100000"/>
               <a:buChar char="•"/>
@@ -8331,14 +7243,14 @@
                 <a:ea typeface="Calibri" pitchFamily="34" charset="-122"/>
                 <a:cs typeface="Calibri" pitchFamily="34" charset="-120"/>
               </a:rPr>
-              <a:t>The three classical strategies are statistically indistinguishable from each other on every task.</a:t>
-            </a:r>
-            <a:endParaRPr lang="en-US" sz="1050" dirty="0"/>
+              <a:t>random / evolutionary / greedy stay statistically indistinguishable from each other on every task.</a:t>
+            </a:r>
+            <a:endParaRPr lang="en-US" sz="1100" dirty="0"/>
           </a:p>
           <a:p>
             <a:pPr marL="342900" indent="-342900">
               <a:spcAft>
-                <a:spcPts val="400"/>
+                <a:spcPts val="500"/>
               </a:spcAft>
               <a:buSzPct val="100000"/>
               <a:buChar char="•"/>
@@ -8352,9 +7264,9 @@
                 <a:ea typeface="Calibri" pitchFamily="34" charset="-122"/>
                 <a:cs typeface="Calibri" pitchFamily="34" charset="-120"/>
               </a:rPr>
-              <a:t>T4 (AUROC ≈ 0.73–0.75) is flat across arms.</a:t>
-            </a:r>
-            <a:endParaRPr lang="en-US" sz="1050" dirty="0"/>
+              <a:t>Scaling (descriptive): on T2 the reference degrades with n (median RMSE 0.070 → 0.295 from n=3 to n=8) while searched arms improve (0.102 → 0.050). All 5/5 paired replicates favour search at n=8, but with 5 reps the smallest attainable paired p is 0.0625, so no Holm-corrected significance is claimed.</a:t>
+            </a:r>
+            <a:endParaRPr lang="en-US" sz="1100" dirty="0"/>
           </a:p>
           <a:p>
             <a:pPr marL="342900" indent="-342900">
@@ -8372,13 +7284,13 @@
               </a:rPr>
               <a:t>This is the bar any LLM arm must beat.</a:t>
             </a:r>
-            <a:endParaRPr lang="en-US" sz="1050" dirty="0"/>
-          </a:p>
-        </p:txBody>
-      </p:sp>
-      <p:sp>
-        <p:nvSpPr>
-          <p:cNvPr id="8" name="Text 3"/>
+            <a:endParaRPr lang="en-US" sz="1100" dirty="0"/>
+          </a:p>
+        </p:txBody>
+      </p:sp>
+      <p:sp>
+        <p:nvSpPr>
+          <p:cNvPr id="10" name="Text 5"/>
           <p:cNvSpPr/>
           <p:nvPr/>
         </p:nvSpPr>
@@ -8409,7 +7321,7 @@
                 <a:ea typeface="Calibri" pitchFamily="34" charset="-122"/>
                 <a:cs typeface="Calibri" pitchFamily="34" charset="-120"/>
               </a:rPr>
-              <a:t>*LLM cells await LLM_API_BUDGET_USD (slide 10). Sources: data/fig_e2_per_seed.csv · data/fig_e2_anytime.csv · data/matrix_status.csv</a:t>
+              <a:t>LLM cells await LLM_API_BUDGET_USD (slide 10). Sources: data/fig_e2_per_seed.csv · data/fig_e2_anytime.csv · data/fig_e3_scaling.csv · data/matrix_status.csv</a:t>
             </a:r>
             <a:endParaRPr lang="en-US" sz="850" dirty="0"/>
           </a:p>

</xml_diff>